<commit_message>
feat(demo): colorful Northstar multi-hue brand + motif series chrome
Indigo stage with violet/cyan/pink/mint/amber series. Map
charts.series_colors into palette series; KPI values, process steps,
funnel bands, card indices, and pillars cycle the series palette.
Rebuild showcase (20 slides, issues=0, animated).
</commit_message>
<xml_diff>
--- a/demo/designmd-pptx-showcase-northstar.pptx
+++ b/demo/designmd-pptx-showcase-northstar.pptx
@@ -5,26 +5,26 @@
     <p:sldMasterId xmlns:r="http://schemas.openxmlformats.org/officeDocument/2006/relationships" id="2147483648" r:id="rId1"/>
   </p:sldMasterIdLst>
   <p:sldIdLst>
-    <p:sldId id="256" r:id="R6e3b413a66e541c6"/>
-    <p:sldId id="257" r:id="Rc7a3ff0f0ca640e9"/>
-    <p:sldId id="258" r:id="R003f84dbbeab4705"/>
-    <p:sldId id="259" r:id="R7cfadbf6a44342ae"/>
-    <p:sldId id="260" r:id="R41c2262769644a6d"/>
-    <p:sldId id="261" r:id="R5c2b402139ba4566"/>
-    <p:sldId id="262" r:id="Re56f64672f7f40cb"/>
-    <p:sldId id="263" r:id="R3f792bd751674256"/>
-    <p:sldId id="264" r:id="Ra10de2463d294d53"/>
-    <p:sldId id="265" r:id="R10d7d17e3e674123"/>
-    <p:sldId id="266" r:id="Ra98e1a4375694e79"/>
-    <p:sldId id="267" r:id="R40d0025b57bf43e2"/>
-    <p:sldId id="268" r:id="R2a242db888594919"/>
-    <p:sldId id="269" r:id="R6be0f48d8edb4a92"/>
-    <p:sldId id="270" r:id="Rc298d8ae9bc94254"/>
-    <p:sldId id="271" r:id="R73ecff9769264198"/>
-    <p:sldId id="272" r:id="R802bb08961a04ee1"/>
-    <p:sldId id="273" r:id="Rf0f43814efd446ad"/>
-    <p:sldId id="274" r:id="Ra21b94a656a4422e"/>
-    <p:sldId id="275" r:id="Rf79989f95df0454f"/>
+    <p:sldId id="256" r:id="R241a62cdc11747c1"/>
+    <p:sldId id="257" r:id="Rcc1e5886056c4d2f"/>
+    <p:sldId id="258" r:id="R669e5fbeb3194298"/>
+    <p:sldId id="259" r:id="R8c74fcf442db46e8"/>
+    <p:sldId id="260" r:id="R2770eb1e4b254ceb"/>
+    <p:sldId id="261" r:id="Rd04c8ac0c08c470a"/>
+    <p:sldId id="262" r:id="R1d8c061868bd4dc0"/>
+    <p:sldId id="263" r:id="Raeafd4775be8403b"/>
+    <p:sldId id="264" r:id="Rd77d64224dfa433c"/>
+    <p:sldId id="265" r:id="R03402697c5034427"/>
+    <p:sldId id="266" r:id="R3d0810a22db04b08"/>
+    <p:sldId id="267" r:id="Rdd4970ab97c9410a"/>
+    <p:sldId id="268" r:id="Rc1daee5607b14fa5"/>
+    <p:sldId id="269" r:id="R6fd3652fcf2a406f"/>
+    <p:sldId id="270" r:id="Rcef0578298f943cd"/>
+    <p:sldId id="271" r:id="R1ad9c8c4bb9b4ba7"/>
+    <p:sldId id="272" r:id="R2cfd90aec3144880"/>
+    <p:sldId id="273" r:id="Rf34844414dc8425a"/>
+    <p:sldId id="274" r:id="R306ca5cd325b49a8"/>
+    <p:sldId id="275" r:id="R406056d7b97c4296"/>
   </p:sldIdLst>
   <p:sldSz cx="12192000" cy="6858000"/>
   <p:notesSz cx="6858000" cy="9144000"/>
@@ -1314,9 +1314,17 @@
   <p:cSld>
     <p:bg>
       <p:bgPr>
-        <a:solidFill xmlns:a="http://schemas.openxmlformats.org/drawingml/2006/main">
-          <a:srgbClr val="000000"/>
-        </a:solidFill>
+        <a:gradFill xmlns:a="http://schemas.openxmlformats.org/drawingml/2006/main">
+          <a:gsLst>
+            <a:gs pos="0">
+              <a:srgbClr val="0B0B1A"/>
+            </a:gs>
+            <a:gs pos="100000">
+              <a:srgbClr val="2A145A"/>
+            </a:gs>
+          </a:gsLst>
+          <a:lin ang="8100000" scaled="1"/>
+        </a:gradFill>
       </p:bgPr>
     </p:bg>
     <p:spTree>
@@ -1341,7 +1349,7 @@
             <a:avLst/>
           </a:prstGeom>
           <a:solidFill xmlns:a="http://schemas.openxmlformats.org/drawingml/2006/main">
-            <a:srgbClr val="0B5FFF"/>
+            <a:srgbClr val="7C5CFF"/>
           </a:solidFill>
           <a:ln xmlns:a="http://schemas.openxmlformats.org/drawingml/2006/main">
             <a:noFill/>
@@ -1377,7 +1385,7 @@
             <a:r>
               <a:rPr lang="en-US" sz="4800" b="1">
                 <a:solidFill>
-                  <a:srgbClr val="F5F5F7"/>
+                  <a:srgbClr val="F4F2FF"/>
                 </a:solidFill>
                 <a:latin typeface="Arial"/>
                 <a:ea typeface="Arial"/>
@@ -1402,7 +1410,7 @@
             <a:avLst/>
           </a:prstGeom>
           <a:solidFill xmlns:a="http://schemas.openxmlformats.org/drawingml/2006/main">
-            <a:srgbClr val="0B5FFF"/>
+            <a:srgbClr val="7C5CFF"/>
           </a:solidFill>
           <a:ln xmlns:a="http://schemas.openxmlformats.org/drawingml/2006/main">
             <a:noFill/>
@@ -1578,7 +1586,7 @@
     <p:bg>
       <p:bgPr>
         <a:solidFill xmlns:a="http://schemas.openxmlformats.org/drawingml/2006/main">
-          <a:srgbClr val="000000"/>
+          <a:srgbClr val="0B0B1A"/>
         </a:solidFill>
       </p:bgPr>
     </p:bg>
@@ -1612,7 +1620,7 @@
             <a:r>
               <a:rPr lang="en-US" sz="3600" b="1">
                 <a:solidFill>
-                  <a:srgbClr val="F5F5F7"/>
+                  <a:srgbClr val="F4F2FF"/>
                 </a:solidFill>
                 <a:latin typeface="Arial"/>
                 <a:ea typeface="Arial"/>
@@ -1637,7 +1645,7 @@
             <a:avLst/>
           </a:prstGeom>
           <a:solidFill xmlns:a="http://schemas.openxmlformats.org/drawingml/2006/main">
-            <a:srgbClr val="0B5FFF"/>
+            <a:srgbClr val="7C5CFF"/>
           </a:solidFill>
           <a:ln xmlns:a="http://schemas.openxmlformats.org/drawingml/2006/main">
             <a:noFill/>
@@ -1770,7 +1778,7 @@
             <a:avLst/>
           </a:prstGeom>
           <a:solidFill xmlns:a="http://schemas.openxmlformats.org/drawingml/2006/main">
-            <a:srgbClr val="1C1C1E"/>
+            <a:srgbClr val="16162E"/>
           </a:solidFill>
           <a:ln xmlns:a="http://schemas.openxmlformats.org/drawingml/2006/main">
             <a:noFill/>
@@ -1784,7 +1792,7 @@
             <a:r>
               <a:rPr lang="en-US" sz="1800" b="1">
                 <a:solidFill>
-                  <a:srgbClr val="F5F5F7"/>
+                  <a:srgbClr val="F4F2FF"/>
                 </a:solidFill>
                 <a:latin typeface="Arial"/>
                 <a:ea typeface="Arial"/>
@@ -1797,7 +1805,7 @@
             <a:r>
               <a:rPr lang="en-US" sz="1800" b="1">
                 <a:solidFill>
-                  <a:srgbClr val="F5F5F7"/>
+                  <a:srgbClr val="F4F2FF"/>
                 </a:solidFill>
                 <a:latin typeface="Arial"/>
                 <a:ea typeface="Arial"/>
@@ -1849,7 +1857,7 @@
             <a:avLst/>
           </a:prstGeom>
           <a:solidFill xmlns:a="http://schemas.openxmlformats.org/drawingml/2006/main">
-            <a:srgbClr val="1C1C1E"/>
+            <a:srgbClr val="16162E"/>
           </a:solidFill>
           <a:ln xmlns:a="http://schemas.openxmlformats.org/drawingml/2006/main">
             <a:noFill/>
@@ -1863,7 +1871,7 @@
             <a:r>
               <a:rPr lang="en-US" sz="1800" b="1">
                 <a:solidFill>
-                  <a:srgbClr val="F5F5F7"/>
+                  <a:srgbClr val="F4F2FF"/>
                 </a:solidFill>
                 <a:latin typeface="Arial"/>
                 <a:ea typeface="Arial"/>
@@ -1876,7 +1884,7 @@
             <a:r>
               <a:rPr lang="en-US" sz="1800" b="1">
                 <a:solidFill>
-                  <a:srgbClr val="F5F5F7"/>
+                  <a:srgbClr val="F4F2FF"/>
                 </a:solidFill>
                 <a:latin typeface="Arial"/>
                 <a:ea typeface="Arial"/>
@@ -1928,7 +1936,7 @@
             <a:avLst/>
           </a:prstGeom>
           <a:solidFill xmlns:a="http://schemas.openxmlformats.org/drawingml/2006/main">
-            <a:srgbClr val="1C1C1E"/>
+            <a:srgbClr val="16162E"/>
           </a:solidFill>
           <a:ln xmlns:a="http://schemas.openxmlformats.org/drawingml/2006/main">
             <a:noFill/>
@@ -1942,7 +1950,7 @@
             <a:r>
               <a:rPr lang="en-US" sz="1800" b="1">
                 <a:solidFill>
-                  <a:srgbClr val="F5F5F7"/>
+                  <a:srgbClr val="F4F2FF"/>
                 </a:solidFill>
                 <a:latin typeface="Arial"/>
                 <a:ea typeface="Arial"/>
@@ -1955,7 +1963,7 @@
             <a:r>
               <a:rPr lang="en-US" sz="1800" b="1">
                 <a:solidFill>
-                  <a:srgbClr val="F5F5F7"/>
+                  <a:srgbClr val="F4F2FF"/>
                 </a:solidFill>
                 <a:latin typeface="Arial"/>
                 <a:ea typeface="Arial"/>
@@ -2078,7 +2086,7 @@
     <p:bg>
       <p:bgPr>
         <a:solidFill xmlns:a="http://schemas.openxmlformats.org/drawingml/2006/main">
-          <a:srgbClr val="000000"/>
+          <a:srgbClr val="0B0B1A"/>
         </a:solidFill>
       </p:bgPr>
     </p:bg>
@@ -2112,7 +2120,7 @@
             <a:r>
               <a:rPr lang="en-US" sz="3600" b="1">
                 <a:solidFill>
-                  <a:srgbClr val="F5F5F7"/>
+                  <a:srgbClr val="F4F2FF"/>
                 </a:solidFill>
                 <a:latin typeface="Arial"/>
                 <a:ea typeface="Arial"/>
@@ -2137,7 +2145,7 @@
             <a:avLst/>
           </a:prstGeom>
           <a:solidFill xmlns:a="http://schemas.openxmlformats.org/drawingml/2006/main">
-            <a:srgbClr val="0B5FFF"/>
+            <a:srgbClr val="7C5CFF"/>
           </a:solidFill>
           <a:ln xmlns:a="http://schemas.openxmlformats.org/drawingml/2006/main">
             <a:noFill/>
@@ -2176,7 +2184,7 @@
             <a:avLst/>
           </a:prstGeom>
           <a:solidFill xmlns:a="http://schemas.openxmlformats.org/drawingml/2006/main">
-            <a:srgbClr val="1C1C1E"/>
+            <a:srgbClr val="16162E"/>
           </a:solidFill>
           <a:ln xmlns:a="http://schemas.openxmlformats.org/drawingml/2006/main">
             <a:noFill/>
@@ -2190,7 +2198,7 @@
             <a:r>
               <a:rPr lang="en-US" sz="1800" b="1">
                 <a:solidFill>
-                  <a:srgbClr val="F5F5F7"/>
+                  <a:srgbClr val="F4F2FF"/>
                 </a:solidFill>
                 <a:latin typeface="Arial"/>
                 <a:ea typeface="Arial"/>
@@ -2215,7 +2223,7 @@
             <a:avLst/>
           </a:prstGeom>
           <a:solidFill xmlns:a="http://schemas.openxmlformats.org/drawingml/2006/main">
-            <a:srgbClr val="1C1C1E"/>
+            <a:srgbClr val="16162E"/>
           </a:solidFill>
           <a:ln xmlns:a="http://schemas.openxmlformats.org/drawingml/2006/main">
             <a:noFill/>
@@ -2229,7 +2237,7 @@
             <a:r>
               <a:rPr lang="en-US" sz="1800" b="1">
                 <a:solidFill>
-                  <a:srgbClr val="F5F5F7"/>
+                  <a:srgbClr val="F4F2FF"/>
                 </a:solidFill>
                 <a:latin typeface="Arial"/>
                 <a:ea typeface="Arial"/>
@@ -2254,7 +2262,7 @@
             <a:avLst/>
           </a:prstGeom>
           <a:solidFill xmlns:a="http://schemas.openxmlformats.org/drawingml/2006/main">
-            <a:srgbClr val="1C1C1E"/>
+            <a:srgbClr val="16162E"/>
           </a:solidFill>
           <a:ln xmlns:a="http://schemas.openxmlformats.org/drawingml/2006/main">
             <a:noFill/>
@@ -2268,7 +2276,7 @@
             <a:r>
               <a:rPr lang="en-US" sz="1800" b="1">
                 <a:solidFill>
-                  <a:srgbClr val="F5F5F7"/>
+                  <a:srgbClr val="F4F2FF"/>
                 </a:solidFill>
                 <a:latin typeface="Arial"/>
                 <a:ea typeface="Arial"/>
@@ -2293,7 +2301,7 @@
             <a:avLst/>
           </a:prstGeom>
           <a:solidFill xmlns:a="http://schemas.openxmlformats.org/drawingml/2006/main">
-            <a:srgbClr val="1C1C1E"/>
+            <a:srgbClr val="16162E"/>
           </a:solidFill>
           <a:ln xmlns:a="http://schemas.openxmlformats.org/drawingml/2006/main">
             <a:noFill/>
@@ -2307,7 +2315,7 @@
             <a:r>
               <a:rPr lang="en-US" sz="1800" b="1">
                 <a:solidFill>
-                  <a:srgbClr val="F5F5F7"/>
+                  <a:srgbClr val="F4F2FF"/>
                 </a:solidFill>
                 <a:latin typeface="Arial"/>
                 <a:ea typeface="Arial"/>
@@ -2430,7 +2438,7 @@
     <p:bg>
       <p:bgPr>
         <a:solidFill xmlns:a="http://schemas.openxmlformats.org/drawingml/2006/main">
-          <a:srgbClr val="000000"/>
+          <a:srgbClr val="0B0B1A"/>
         </a:solidFill>
       </p:bgPr>
     </p:bg>
@@ -2464,7 +2472,7 @@
             <a:r>
               <a:rPr lang="en-US" sz="3600" b="1">
                 <a:solidFill>
-                  <a:srgbClr val="F5F5F7"/>
+                  <a:srgbClr val="F4F2FF"/>
                 </a:solidFill>
                 <a:latin typeface="Arial"/>
                 <a:ea typeface="Arial"/>
@@ -2489,7 +2497,7 @@
             <a:avLst/>
           </a:prstGeom>
           <a:solidFill xmlns:a="http://schemas.openxmlformats.org/drawingml/2006/main">
-            <a:srgbClr val="3A3A3C"/>
+            <a:srgbClr val="3A3570"/>
           </a:solidFill>
           <a:ln xmlns:a="http://schemas.openxmlformats.org/drawingml/2006/main">
             <a:noFill/>
@@ -2525,7 +2533,7 @@
             <a:r>
               <a:rPr lang="en-US" sz="2000" b="1">
                 <a:solidFill>
-                  <a:srgbClr val="F5F5F7"/>
+                  <a:srgbClr val="F4F2FF"/>
                 </a:solidFill>
                 <a:latin typeface="Arial"/>
                 <a:ea typeface="Arial"/>
@@ -2593,7 +2601,7 @@
             <a:r>
               <a:rPr lang="en-US" sz="2000" b="1">
                 <a:solidFill>
-                  <a:srgbClr val="F5F5F7"/>
+                  <a:srgbClr val="F4F2FF"/>
                 </a:solidFill>
                 <a:latin typeface="Arial"/>
                 <a:ea typeface="Arial"/>
@@ -2661,7 +2669,7 @@
             <a:r>
               <a:rPr lang="en-US" sz="2000" b="1">
                 <a:solidFill>
-                  <a:srgbClr val="F5F5F7"/>
+                  <a:srgbClr val="F4F2FF"/>
                 </a:solidFill>
                 <a:latin typeface="Arial"/>
                 <a:ea typeface="Arial"/>
@@ -2729,7 +2737,7 @@
             <a:r>
               <a:rPr lang="en-US" sz="2000" b="1">
                 <a:solidFill>
-                  <a:srgbClr val="F5F5F7"/>
+                  <a:srgbClr val="F4F2FF"/>
                 </a:solidFill>
                 <a:latin typeface="Arial"/>
                 <a:ea typeface="Arial"/>
@@ -2788,7 +2796,7 @@
             <a:avLst/>
           </a:prstGeom>
           <a:solidFill xmlns:a="http://schemas.openxmlformats.org/drawingml/2006/main">
-            <a:srgbClr val="0B5FFF"/>
+            <a:srgbClr val="7C5CFF"/>
           </a:solidFill>
           <a:ln xmlns:a="http://schemas.openxmlformats.org/drawingml/2006/main">
             <a:noFill/>
@@ -2815,7 +2823,7 @@
             <a:avLst/>
           </a:prstGeom>
           <a:solidFill xmlns:a="http://schemas.openxmlformats.org/drawingml/2006/main">
-            <a:srgbClr val="0B5FFF"/>
+            <a:srgbClr val="7C5CFF"/>
           </a:solidFill>
           <a:ln xmlns:a="http://schemas.openxmlformats.org/drawingml/2006/main">
             <a:noFill/>
@@ -2842,7 +2850,7 @@
             <a:avLst/>
           </a:prstGeom>
           <a:solidFill xmlns:a="http://schemas.openxmlformats.org/drawingml/2006/main">
-            <a:srgbClr val="0B5FFF"/>
+            <a:srgbClr val="7C5CFF"/>
           </a:solidFill>
           <a:ln xmlns:a="http://schemas.openxmlformats.org/drawingml/2006/main">
             <a:noFill/>
@@ -2869,7 +2877,7 @@
             <a:avLst/>
           </a:prstGeom>
           <a:solidFill xmlns:a="http://schemas.openxmlformats.org/drawingml/2006/main">
-            <a:srgbClr val="0B5FFF"/>
+            <a:srgbClr val="7C5CFF"/>
           </a:solidFill>
           <a:ln xmlns:a="http://schemas.openxmlformats.org/drawingml/2006/main">
             <a:noFill/>
@@ -2994,7 +3002,7 @@
     <p:bg>
       <p:bgPr>
         <a:solidFill xmlns:a="http://schemas.openxmlformats.org/drawingml/2006/main">
-          <a:srgbClr val="000000"/>
+          <a:srgbClr val="0B0B1A"/>
         </a:solidFill>
       </p:bgPr>
     </p:bg>
@@ -3028,7 +3036,7 @@
             <a:r>
               <a:rPr lang="en-US" sz="3600" b="1">
                 <a:solidFill>
-                  <a:srgbClr val="F5F5F7"/>
+                  <a:srgbClr val="F4F2FF"/>
                 </a:solidFill>
                 <a:latin typeface="Arial"/>
                 <a:ea typeface="Arial"/>
@@ -3053,7 +3061,7 @@
             <a:avLst/>
           </a:prstGeom>
           <a:solidFill xmlns:a="http://schemas.openxmlformats.org/drawingml/2006/main">
-            <a:srgbClr val="0B5FFF"/>
+            <a:srgbClr val="7C5CFF"/>
           </a:solidFill>
           <a:ln xmlns:a="http://schemas.openxmlformats.org/drawingml/2006/main">
             <a:noFill/>
@@ -3118,7 +3126,7 @@
             <a:avLst/>
           </a:prstGeom>
           <a:solidFill xmlns:a="http://schemas.openxmlformats.org/drawingml/2006/main">
-            <a:srgbClr val="1C1C1E"/>
+            <a:srgbClr val="22D3EE"/>
           </a:solidFill>
           <a:ln xmlns:a="http://schemas.openxmlformats.org/drawingml/2006/main">
             <a:noFill/>
@@ -3132,7 +3140,7 @@
             <a:r>
               <a:rPr lang="en-US" sz="2400" b="1">
                 <a:solidFill>
-                  <a:srgbClr val="F5F5F7"/>
+                  <a:srgbClr val="FFFFFF"/>
                 </a:solidFill>
                 <a:latin typeface="Arial"/>
                 <a:ea typeface="Arial"/>
@@ -3145,7 +3153,7 @@
             <a:r>
               <a:rPr lang="en-US" sz="2400" b="1">
                 <a:solidFill>
-                  <a:srgbClr val="F5F5F7"/>
+                  <a:srgbClr val="FFFFFF"/>
                 </a:solidFill>
                 <a:latin typeface="Arial"/>
                 <a:ea typeface="Arial"/>
@@ -3158,7 +3166,7 @@
             <a:r>
               <a:rPr lang="en-US" sz="2400" b="1">
                 <a:solidFill>
-                  <a:srgbClr val="F5F5F7"/>
+                  <a:srgbClr val="FFFFFF"/>
                 </a:solidFill>
                 <a:latin typeface="Arial"/>
                 <a:ea typeface="Arial"/>
@@ -3183,7 +3191,7 @@
             <a:avLst/>
           </a:prstGeom>
           <a:solidFill xmlns:a="http://schemas.openxmlformats.org/drawingml/2006/main">
-            <a:srgbClr val="1C1C1E"/>
+            <a:srgbClr val="F472B6"/>
           </a:solidFill>
           <a:ln xmlns:a="http://schemas.openxmlformats.org/drawingml/2006/main">
             <a:noFill/>
@@ -3197,7 +3205,7 @@
             <a:r>
               <a:rPr lang="en-US" sz="2400" b="1">
                 <a:solidFill>
-                  <a:srgbClr val="F5F5F7"/>
+                  <a:srgbClr val="FFFFFF"/>
                 </a:solidFill>
                 <a:latin typeface="Arial"/>
                 <a:ea typeface="Arial"/>
@@ -3210,7 +3218,7 @@
             <a:r>
               <a:rPr lang="en-US" sz="2400" b="1">
                 <a:solidFill>
-                  <a:srgbClr val="F5F5F7"/>
+                  <a:srgbClr val="FFFFFF"/>
                 </a:solidFill>
                 <a:latin typeface="Arial"/>
                 <a:ea typeface="Arial"/>
@@ -3223,7 +3231,7 @@
             <a:r>
               <a:rPr lang="en-US" sz="2400" b="1">
                 <a:solidFill>
-                  <a:srgbClr val="F5F5F7"/>
+                  <a:srgbClr val="FFFFFF"/>
                 </a:solidFill>
                 <a:latin typeface="Arial"/>
                 <a:ea typeface="Arial"/>
@@ -3346,7 +3354,7 @@
     <p:bg>
       <p:bgPr>
         <a:solidFill xmlns:a="http://schemas.openxmlformats.org/drawingml/2006/main">
-          <a:srgbClr val="000000"/>
+          <a:srgbClr val="0B0B1A"/>
         </a:solidFill>
       </p:bgPr>
     </p:bg>
@@ -3380,7 +3388,7 @@
             <a:r>
               <a:rPr lang="en-US" sz="3600" b="1">
                 <a:solidFill>
-                  <a:srgbClr val="F5F5F7"/>
+                  <a:srgbClr val="F4F2FF"/>
                 </a:solidFill>
                 <a:latin typeface="Arial"/>
                 <a:ea typeface="Arial"/>
@@ -3405,7 +3413,7 @@
             <a:avLst/>
           </a:prstGeom>
           <a:solidFill xmlns:a="http://schemas.openxmlformats.org/drawingml/2006/main">
-            <a:srgbClr val="1C1C1E"/>
+            <a:srgbClr val="16162E"/>
           </a:solidFill>
           <a:ln xmlns:a="http://schemas.openxmlformats.org/drawingml/2006/main">
             <a:noFill/>
@@ -3440,7 +3448,7 @@
             <a:r>
               <a:rPr lang="en-US" sz="2400" b="1">
                 <a:solidFill>
-                  <a:srgbClr val="F5F5F7"/>
+                  <a:srgbClr val="F4F2FF"/>
                 </a:solidFill>
                 <a:latin typeface="Arial"/>
                 <a:ea typeface="Arial"/>
@@ -3498,7 +3506,7 @@
             <a:avLst/>
           </a:prstGeom>
           <a:solidFill xmlns:a="http://schemas.openxmlformats.org/drawingml/2006/main">
-            <a:srgbClr val="1C1C1E"/>
+            <a:srgbClr val="16162E"/>
           </a:solidFill>
           <a:ln xmlns:a="http://schemas.openxmlformats.org/drawingml/2006/main">
             <a:noFill/>
@@ -3533,7 +3541,7 @@
             <a:r>
               <a:rPr lang="en-US" sz="2400" b="1">
                 <a:solidFill>
-                  <a:srgbClr val="F5F5F7"/>
+                  <a:srgbClr val="F4F2FF"/>
                 </a:solidFill>
                 <a:latin typeface="Arial"/>
                 <a:ea typeface="Arial"/>
@@ -3591,7 +3599,7 @@
             <a:avLst/>
           </a:prstGeom>
           <a:solidFill xmlns:a="http://schemas.openxmlformats.org/drawingml/2006/main">
-            <a:srgbClr val="1C1C1E"/>
+            <a:srgbClr val="16162E"/>
           </a:solidFill>
           <a:ln xmlns:a="http://schemas.openxmlformats.org/drawingml/2006/main">
             <a:noFill/>
@@ -3626,7 +3634,7 @@
             <a:r>
               <a:rPr lang="en-US" sz="2400" b="1">
                 <a:solidFill>
-                  <a:srgbClr val="F5F5F7"/>
+                  <a:srgbClr val="F4F2FF"/>
                 </a:solidFill>
                 <a:latin typeface="Arial"/>
                 <a:ea typeface="Arial"/>
@@ -3684,7 +3692,7 @@
             <a:avLst/>
           </a:prstGeom>
           <a:solidFill xmlns:a="http://schemas.openxmlformats.org/drawingml/2006/main">
-            <a:srgbClr val="1C1C1E"/>
+            <a:srgbClr val="16162E"/>
           </a:solidFill>
           <a:ln xmlns:a="http://schemas.openxmlformats.org/drawingml/2006/main">
             <a:noFill/>
@@ -3719,7 +3727,7 @@
             <a:r>
               <a:rPr lang="en-US" sz="2400" b="1">
                 <a:solidFill>
-                  <a:srgbClr val="F5F5F7"/>
+                  <a:srgbClr val="F4F2FF"/>
                 </a:solidFill>
                 <a:latin typeface="Arial"/>
                 <a:ea typeface="Arial"/>
@@ -3942,7 +3950,7 @@
     <p:bg>
       <p:bgPr>
         <a:solidFill xmlns:a="http://schemas.openxmlformats.org/drawingml/2006/main">
-          <a:srgbClr val="000000"/>
+          <a:srgbClr val="0B0B1A"/>
         </a:solidFill>
       </p:bgPr>
     </p:bg>
@@ -3976,7 +3984,7 @@
             <a:r>
               <a:rPr lang="en-US" sz="3600" b="1">
                 <a:solidFill>
-                  <a:srgbClr val="F5F5F7"/>
+                  <a:srgbClr val="F4F2FF"/>
                 </a:solidFill>
                 <a:latin typeface="Arial"/>
                 <a:ea typeface="Arial"/>
@@ -4010,7 +4018,7 @@
             <a:r>
               <a:rPr lang="en-US" sz="1800" b="1">
                 <a:solidFill>
-                  <a:srgbClr val="0B5FFF"/>
+                  <a:srgbClr val="7C5CFF"/>
                 </a:solidFill>
                 <a:latin typeface="Arial"/>
                 <a:ea typeface="Arial"/>
@@ -4044,7 +4052,7 @@
             <a:r>
               <a:rPr lang="en-US" sz="1800" b="1">
                 <a:solidFill>
-                  <a:srgbClr val="0B5FFF"/>
+                  <a:srgbClr val="7C5CFF"/>
                 </a:solidFill>
                 <a:latin typeface="Arial"/>
                 <a:ea typeface="Arial"/>
@@ -4078,7 +4086,7 @@
             <a:r>
               <a:rPr lang="en-US" sz="1800" b="1">
                 <a:solidFill>
-                  <a:srgbClr val="0B5FFF"/>
+                  <a:srgbClr val="7C5CFF"/>
                 </a:solidFill>
                 <a:latin typeface="Arial"/>
                 <a:ea typeface="Arial"/>
@@ -4111,7 +4119,7 @@
             <a:r>
               <a:rPr lang="en-US" sz="1800" b="1">
                 <a:solidFill>
-                  <a:srgbClr val="F5F5F7"/>
+                  <a:srgbClr val="F4F2FF"/>
                 </a:solidFill>
                 <a:latin typeface="Arial"/>
                 <a:ea typeface="Arial"/>
@@ -4136,11 +4144,11 @@
             <a:avLst/>
           </a:prstGeom>
           <a:solidFill xmlns:a="http://schemas.openxmlformats.org/drawingml/2006/main">
-            <a:srgbClr val="1C1C1E"/>
+            <a:srgbClr val="16162E"/>
           </a:solidFill>
           <a:ln xmlns:a="http://schemas.openxmlformats.org/drawingml/2006/main">
             <a:solidFill>
-              <a:srgbClr val="3A3A3C"/>
+              <a:srgbClr val="3A3570"/>
             </a:solidFill>
           </a:ln>
         </p:spPr>
@@ -4173,7 +4181,7 @@
             <a:r>
               <a:rPr lang="en-US" sz="1400">
                 <a:solidFill>
-                  <a:srgbClr val="F5F5F7"/>
+                  <a:srgbClr val="F4F2FF"/>
                 </a:solidFill>
                 <a:latin typeface="Arial"/>
                 <a:ea typeface="Arial"/>
@@ -4198,11 +4206,11 @@
             <a:avLst/>
           </a:prstGeom>
           <a:solidFill xmlns:a="http://schemas.openxmlformats.org/drawingml/2006/main">
-            <a:srgbClr val="1C1C1E"/>
+            <a:srgbClr val="16162E"/>
           </a:solidFill>
           <a:ln xmlns:a="http://schemas.openxmlformats.org/drawingml/2006/main">
             <a:solidFill>
-              <a:srgbClr val="3A3A3C"/>
+              <a:srgbClr val="3A3570"/>
             </a:solidFill>
           </a:ln>
         </p:spPr>
@@ -4235,7 +4243,7 @@
             <a:r>
               <a:rPr lang="en-US" sz="1400">
                 <a:solidFill>
-                  <a:srgbClr val="F5F5F7"/>
+                  <a:srgbClr val="F4F2FF"/>
                 </a:solidFill>
                 <a:latin typeface="Arial"/>
                 <a:ea typeface="Arial"/>
@@ -4260,11 +4268,11 @@
             <a:avLst/>
           </a:prstGeom>
           <a:solidFill xmlns:a="http://schemas.openxmlformats.org/drawingml/2006/main">
-            <a:srgbClr val="1C1C1E"/>
+            <a:srgbClr val="16162E"/>
           </a:solidFill>
           <a:ln xmlns:a="http://schemas.openxmlformats.org/drawingml/2006/main">
             <a:solidFill>
-              <a:srgbClr val="3A3A3C"/>
+              <a:srgbClr val="3A3570"/>
             </a:solidFill>
           </a:ln>
         </p:spPr>
@@ -4297,7 +4305,7 @@
             <a:r>
               <a:rPr lang="en-US" sz="1400">
                 <a:solidFill>
-                  <a:srgbClr val="F5F5F7"/>
+                  <a:srgbClr val="F4F2FF"/>
                 </a:solidFill>
                 <a:latin typeface="Arial"/>
                 <a:ea typeface="Arial"/>
@@ -4330,7 +4338,7 @@
             <a:r>
               <a:rPr lang="en-US" sz="1800" b="1">
                 <a:solidFill>
-                  <a:srgbClr val="F5F5F7"/>
+                  <a:srgbClr val="F4F2FF"/>
                 </a:solidFill>
                 <a:latin typeface="Arial"/>
                 <a:ea typeface="Arial"/>
@@ -4355,11 +4363,11 @@
             <a:avLst/>
           </a:prstGeom>
           <a:solidFill xmlns:a="http://schemas.openxmlformats.org/drawingml/2006/main">
-            <a:srgbClr val="1C1C1E"/>
+            <a:srgbClr val="16162E"/>
           </a:solidFill>
           <a:ln xmlns:a="http://schemas.openxmlformats.org/drawingml/2006/main">
             <a:solidFill>
-              <a:srgbClr val="3A3A3C"/>
+              <a:srgbClr val="3A3570"/>
             </a:solidFill>
           </a:ln>
         </p:spPr>
@@ -4392,7 +4400,7 @@
             <a:r>
               <a:rPr lang="en-US" sz="1400">
                 <a:solidFill>
-                  <a:srgbClr val="F5F5F7"/>
+                  <a:srgbClr val="F4F2FF"/>
                 </a:solidFill>
                 <a:latin typeface="Arial"/>
                 <a:ea typeface="Arial"/>
@@ -4417,11 +4425,11 @@
             <a:avLst/>
           </a:prstGeom>
           <a:solidFill xmlns:a="http://schemas.openxmlformats.org/drawingml/2006/main">
-            <a:srgbClr val="1C1C1E"/>
+            <a:srgbClr val="16162E"/>
           </a:solidFill>
           <a:ln xmlns:a="http://schemas.openxmlformats.org/drawingml/2006/main">
             <a:solidFill>
-              <a:srgbClr val="3A3A3C"/>
+              <a:srgbClr val="3A3570"/>
             </a:solidFill>
           </a:ln>
         </p:spPr>
@@ -4454,7 +4462,7 @@
             <a:r>
               <a:rPr lang="en-US" sz="1400">
                 <a:solidFill>
-                  <a:srgbClr val="F5F5F7"/>
+                  <a:srgbClr val="F4F2FF"/>
                 </a:solidFill>
                 <a:latin typeface="Arial"/>
                 <a:ea typeface="Arial"/>
@@ -4479,11 +4487,11 @@
             <a:avLst/>
           </a:prstGeom>
           <a:solidFill xmlns:a="http://schemas.openxmlformats.org/drawingml/2006/main">
-            <a:srgbClr val="1C1C1E"/>
+            <a:srgbClr val="16162E"/>
           </a:solidFill>
           <a:ln xmlns:a="http://schemas.openxmlformats.org/drawingml/2006/main">
             <a:solidFill>
-              <a:srgbClr val="3A3A3C"/>
+              <a:srgbClr val="3A3570"/>
             </a:solidFill>
           </a:ln>
         </p:spPr>
@@ -4516,7 +4524,7 @@
             <a:r>
               <a:rPr lang="en-US" sz="1400">
                 <a:solidFill>
-                  <a:srgbClr val="F5F5F7"/>
+                  <a:srgbClr val="F4F2FF"/>
                 </a:solidFill>
                 <a:latin typeface="Arial"/>
                 <a:ea typeface="Arial"/>
@@ -4549,7 +4557,7 @@
             <a:r>
               <a:rPr lang="en-US" sz="1800" b="1">
                 <a:solidFill>
-                  <a:srgbClr val="F5F5F7"/>
+                  <a:srgbClr val="F4F2FF"/>
                 </a:solidFill>
                 <a:latin typeface="Arial"/>
                 <a:ea typeface="Arial"/>
@@ -4574,11 +4582,11 @@
             <a:avLst/>
           </a:prstGeom>
           <a:solidFill xmlns:a="http://schemas.openxmlformats.org/drawingml/2006/main">
-            <a:srgbClr val="1C1C1E"/>
+            <a:srgbClr val="16162E"/>
           </a:solidFill>
           <a:ln xmlns:a="http://schemas.openxmlformats.org/drawingml/2006/main">
             <a:solidFill>
-              <a:srgbClr val="3A3A3C"/>
+              <a:srgbClr val="3A3570"/>
             </a:solidFill>
           </a:ln>
         </p:spPr>
@@ -4611,7 +4619,7 @@
             <a:r>
               <a:rPr lang="en-US" sz="1400">
                 <a:solidFill>
-                  <a:srgbClr val="F5F5F7"/>
+                  <a:srgbClr val="F4F2FF"/>
                 </a:solidFill>
                 <a:latin typeface="Arial"/>
                 <a:ea typeface="Arial"/>
@@ -4636,11 +4644,11 @@
             <a:avLst/>
           </a:prstGeom>
           <a:solidFill xmlns:a="http://schemas.openxmlformats.org/drawingml/2006/main">
-            <a:srgbClr val="1C1C1E"/>
+            <a:srgbClr val="16162E"/>
           </a:solidFill>
           <a:ln xmlns:a="http://schemas.openxmlformats.org/drawingml/2006/main">
             <a:solidFill>
-              <a:srgbClr val="3A3A3C"/>
+              <a:srgbClr val="3A3570"/>
             </a:solidFill>
           </a:ln>
         </p:spPr>
@@ -4673,7 +4681,7 @@
             <a:r>
               <a:rPr lang="en-US" sz="1400">
                 <a:solidFill>
-                  <a:srgbClr val="F5F5F7"/>
+                  <a:srgbClr val="F4F2FF"/>
                 </a:solidFill>
                 <a:latin typeface="Arial"/>
                 <a:ea typeface="Arial"/>
@@ -4698,11 +4706,11 @@
             <a:avLst/>
           </a:prstGeom>
           <a:solidFill xmlns:a="http://schemas.openxmlformats.org/drawingml/2006/main">
-            <a:srgbClr val="1C1C1E"/>
+            <a:srgbClr val="16162E"/>
           </a:solidFill>
           <a:ln xmlns:a="http://schemas.openxmlformats.org/drawingml/2006/main">
             <a:solidFill>
-              <a:srgbClr val="3A3A3C"/>
+              <a:srgbClr val="3A3570"/>
             </a:solidFill>
           </a:ln>
         </p:spPr>
@@ -4735,7 +4743,7 @@
             <a:r>
               <a:rPr lang="en-US" sz="1400">
                 <a:solidFill>
-                  <a:srgbClr val="F5F5F7"/>
+                  <a:srgbClr val="F4F2FF"/>
                 </a:solidFill>
                 <a:latin typeface="Arial"/>
                 <a:ea typeface="Arial"/>
@@ -4858,7 +4866,7 @@
     <p:bg>
       <p:bgPr>
         <a:solidFill xmlns:a="http://schemas.openxmlformats.org/drawingml/2006/main">
-          <a:srgbClr val="000000"/>
+          <a:srgbClr val="0B0B1A"/>
         </a:solidFill>
       </p:bgPr>
     </p:bg>
@@ -4892,7 +4900,7 @@
             <a:r>
               <a:rPr lang="en-US" sz="3600" b="1">
                 <a:solidFill>
-                  <a:srgbClr val="F5F5F7"/>
+                  <a:srgbClr val="F4F2FF"/>
                 </a:solidFill>
                 <a:latin typeface="Arial"/>
                 <a:ea typeface="Arial"/>
@@ -4917,11 +4925,11 @@
             <a:avLst/>
           </a:prstGeom>
           <a:solidFill xmlns:a="http://schemas.openxmlformats.org/drawingml/2006/main">
-            <a:srgbClr val="1C1C1E"/>
+            <a:srgbClr val="16162E"/>
           </a:solidFill>
           <a:ln xmlns:a="http://schemas.openxmlformats.org/drawingml/2006/main">
             <a:solidFill>
-              <a:srgbClr val="3A3A3C"/>
+              <a:srgbClr val="3A3570"/>
             </a:solidFill>
           </a:ln>
         </p:spPr>
@@ -4955,7 +4963,7 @@
             <a:r>
               <a:rPr lang="en-US" sz="2400" b="1">
                 <a:solidFill>
-                  <a:srgbClr val="F5F5F7"/>
+                  <a:srgbClr val="F4F2FF"/>
                 </a:solidFill>
                 <a:latin typeface="Arial"/>
                 <a:ea typeface="Arial"/>
@@ -4989,7 +4997,7 @@
             <a:r>
               <a:rPr lang="en-US" sz="6000" b="1">
                 <a:solidFill>
-                  <a:srgbClr val="F5F5F7"/>
+                  <a:srgbClr val="F4F2FF"/>
                 </a:solidFill>
                 <a:latin typeface="Arial"/>
                 <a:ea typeface="Arial"/>
@@ -5090,7 +5098,7 @@
             <a:avLst/>
           </a:prstGeom>
           <a:solidFill xmlns:a="http://schemas.openxmlformats.org/drawingml/2006/main">
-            <a:srgbClr val="0B5FFF"/>
+            <a:srgbClr val="7C5CFF"/>
           </a:solidFill>
           <a:ln xmlns:a="http://schemas.openxmlformats.org/drawingml/2006/main">
             <a:noFill/>
@@ -5261,11 +5269,11 @@
             <a:avLst/>
           </a:prstGeom>
           <a:solidFill xmlns:a="http://schemas.openxmlformats.org/drawingml/2006/main">
-            <a:srgbClr val="1C1C1E"/>
+            <a:srgbClr val="16162E"/>
           </a:solidFill>
           <a:ln xmlns:a="http://schemas.openxmlformats.org/drawingml/2006/main">
             <a:solidFill>
-              <a:srgbClr val="3A3A3C"/>
+              <a:srgbClr val="3A3570"/>
             </a:solidFill>
           </a:ln>
         </p:spPr>
@@ -5299,7 +5307,7 @@
             <a:r>
               <a:rPr lang="en-US" sz="2400" b="1">
                 <a:solidFill>
-                  <a:srgbClr val="F5F5F7"/>
+                  <a:srgbClr val="F4F2FF"/>
                 </a:solidFill>
                 <a:latin typeface="Arial"/>
                 <a:ea typeface="Arial"/>
@@ -5333,7 +5341,7 @@
             <a:r>
               <a:rPr lang="en-US" sz="6000" b="1">
                 <a:solidFill>
-                  <a:srgbClr val="F5F5F7"/>
+                  <a:srgbClr val="F4F2FF"/>
                 </a:solidFill>
                 <a:latin typeface="Arial"/>
                 <a:ea typeface="Arial"/>
@@ -5532,7 +5540,7 @@
     <p:bg>
       <p:bgPr>
         <a:solidFill xmlns:a="http://schemas.openxmlformats.org/drawingml/2006/main">
-          <a:srgbClr val="000000"/>
+          <a:srgbClr val="0B0B1A"/>
         </a:solidFill>
       </p:bgPr>
     </p:bg>
@@ -5566,7 +5574,7 @@
             <a:r>
               <a:rPr lang="en-US" sz="3600" b="1">
                 <a:solidFill>
-                  <a:srgbClr val="F5F5F7"/>
+                  <a:srgbClr val="F4F2FF"/>
                 </a:solidFill>
                 <a:latin typeface="Arial"/>
                 <a:ea typeface="Arial"/>
@@ -5795,7 +5803,7 @@
             <a:avLst/>
           </a:prstGeom>
           <a:solidFill xmlns:a="http://schemas.openxmlformats.org/drawingml/2006/main">
-            <a:srgbClr val="1C1C1E"/>
+            <a:srgbClr val="16162E"/>
           </a:solidFill>
           <a:ln xmlns:a="http://schemas.openxmlformats.org/drawingml/2006/main">
             <a:noFill/>
@@ -5822,7 +5830,7 @@
             <a:avLst/>
           </a:prstGeom>
           <a:solidFill xmlns:a="http://schemas.openxmlformats.org/drawingml/2006/main">
-            <a:srgbClr val="1C1C1E"/>
+            <a:srgbClr val="16162E"/>
           </a:solidFill>
           <a:ln xmlns:a="http://schemas.openxmlformats.org/drawingml/2006/main">
             <a:noFill/>
@@ -5849,7 +5857,7 @@
             <a:avLst/>
           </a:prstGeom>
           <a:solidFill xmlns:a="http://schemas.openxmlformats.org/drawingml/2006/main">
-            <a:srgbClr val="91B7FF"/>
+            <a:srgbClr val="22D3EE"/>
           </a:solidFill>
           <a:ln xmlns:a="http://schemas.openxmlformats.org/drawingml/2006/main">
             <a:noFill/>
@@ -5876,7 +5884,7 @@
             <a:avLst/>
           </a:prstGeom>
           <a:solidFill xmlns:a="http://schemas.openxmlformats.org/drawingml/2006/main">
-            <a:srgbClr val="1C1C1E"/>
+            <a:srgbClr val="16162E"/>
           </a:solidFill>
           <a:ln xmlns:a="http://schemas.openxmlformats.org/drawingml/2006/main">
             <a:noFill/>
@@ -5903,7 +5911,7 @@
             <a:avLst/>
           </a:prstGeom>
           <a:solidFill xmlns:a="http://schemas.openxmlformats.org/drawingml/2006/main">
-            <a:srgbClr val="91B7FF"/>
+            <a:srgbClr val="22D3EE"/>
           </a:solidFill>
           <a:ln xmlns:a="http://schemas.openxmlformats.org/drawingml/2006/main">
             <a:noFill/>
@@ -5930,7 +5938,7 @@
             <a:avLst/>
           </a:prstGeom>
           <a:solidFill xmlns:a="http://schemas.openxmlformats.org/drawingml/2006/main">
-            <a:srgbClr val="0B5FFF"/>
+            <a:srgbClr val="7C5CFF"/>
           </a:solidFill>
           <a:ln xmlns:a="http://schemas.openxmlformats.org/drawingml/2006/main">
             <a:noFill/>
@@ -5957,7 +5965,7 @@
             <a:avLst/>
           </a:prstGeom>
           <a:solidFill xmlns:a="http://schemas.openxmlformats.org/drawingml/2006/main">
-            <a:srgbClr val="91B7FF"/>
+            <a:srgbClr val="22D3EE"/>
           </a:solidFill>
           <a:ln xmlns:a="http://schemas.openxmlformats.org/drawingml/2006/main">
             <a:noFill/>
@@ -5984,7 +5992,7 @@
             <a:avLst/>
           </a:prstGeom>
           <a:solidFill xmlns:a="http://schemas.openxmlformats.org/drawingml/2006/main">
-            <a:srgbClr val="0B5FFF"/>
+            <a:srgbClr val="7C5CFF"/>
           </a:solidFill>
           <a:ln xmlns:a="http://schemas.openxmlformats.org/drawingml/2006/main">
             <a:noFill/>
@@ -6011,7 +6019,7 @@
             <a:avLst/>
           </a:prstGeom>
           <a:solidFill xmlns:a="http://schemas.openxmlformats.org/drawingml/2006/main">
-            <a:srgbClr val="0B5FFF"/>
+            <a:srgbClr val="7C5CFF"/>
           </a:solidFill>
           <a:ln xmlns:a="http://schemas.openxmlformats.org/drawingml/2006/main">
             <a:noFill/>
@@ -6047,7 +6055,7 @@
             <a:r>
               <a:rPr lang="en-US" sz="1400" b="1">
                 <a:solidFill>
-                  <a:srgbClr val="F5F5F7"/>
+                  <a:srgbClr val="F4F2FF"/>
                 </a:solidFill>
                 <a:latin typeface="Arial"/>
                 <a:ea typeface="Arial"/>
@@ -6081,7 +6089,7 @@
             <a:r>
               <a:rPr lang="en-US" sz="1400" b="1">
                 <a:solidFill>
-                  <a:srgbClr val="F5F5F7"/>
+                  <a:srgbClr val="F4F2FF"/>
                 </a:solidFill>
                 <a:latin typeface="Arial"/>
                 <a:ea typeface="Arial"/>
@@ -6115,7 +6123,7 @@
             <a:r>
               <a:rPr lang="en-US" sz="1400" b="1">
                 <a:solidFill>
-                  <a:srgbClr val="F5F5F7"/>
+                  <a:srgbClr val="F4F2FF"/>
                 </a:solidFill>
                 <a:latin typeface="Arial"/>
                 <a:ea typeface="Arial"/>
@@ -6149,7 +6157,7 @@
             <a:r>
               <a:rPr lang="en-US" sz="1400" b="1">
                 <a:solidFill>
-                  <a:srgbClr val="F5F5F7"/>
+                  <a:srgbClr val="F4F2FF"/>
                 </a:solidFill>
                 <a:latin typeface="Arial"/>
                 <a:ea typeface="Arial"/>
@@ -6306,7 +6314,7 @@
     <p:bg>
       <p:bgPr>
         <a:solidFill xmlns:a="http://schemas.openxmlformats.org/drawingml/2006/main">
-          <a:srgbClr val="000000"/>
+          <a:srgbClr val="0B0B1A"/>
         </a:solidFill>
       </p:bgPr>
     </p:bg>
@@ -6340,7 +6348,7 @@
             <a:r>
               <a:rPr lang="en-US" sz="3600" b="1">
                 <a:solidFill>
-                  <a:srgbClr val="F5F5F7"/>
+                  <a:srgbClr val="F4F2FF"/>
                 </a:solidFill>
                 <a:latin typeface="Arial"/>
                 <a:ea typeface="Arial"/>
@@ -6398,7 +6406,7 @@
             <a:avLst/>
           </a:prstGeom>
           <a:solidFill xmlns:a="http://schemas.openxmlformats.org/drawingml/2006/main">
-            <a:srgbClr val="1C1C1E"/>
+            <a:srgbClr val="16162E"/>
           </a:solidFill>
           <a:ln xmlns:a="http://schemas.openxmlformats.org/drawingml/2006/main">
             <a:noFill/>
@@ -6433,7 +6441,7 @@
             <a:r>
               <a:rPr lang="en-US" sz="1800" b="1">
                 <a:solidFill>
-                  <a:srgbClr val="F5F5F7"/>
+                  <a:srgbClr val="F4F2FF"/>
                 </a:solidFill>
                 <a:latin typeface="Arial"/>
                 <a:ea typeface="Arial"/>
@@ -6458,7 +6466,7 @@
             <a:avLst/>
           </a:prstGeom>
           <a:solidFill xmlns:a="http://schemas.openxmlformats.org/drawingml/2006/main">
-            <a:srgbClr val="30D158"/>
+            <a:srgbClr val="3DDC97"/>
           </a:solidFill>
           <a:ln xmlns:a="http://schemas.openxmlformats.org/drawingml/2006/main">
             <a:noFill/>
@@ -6518,7 +6526,7 @@
             <a:avLst/>
           </a:prstGeom>
           <a:solidFill xmlns:a="http://schemas.openxmlformats.org/drawingml/2006/main">
-            <a:srgbClr val="1C1C1E"/>
+            <a:srgbClr val="16162E"/>
           </a:solidFill>
           <a:ln xmlns:a="http://schemas.openxmlformats.org/drawingml/2006/main">
             <a:noFill/>
@@ -6553,7 +6561,7 @@
             <a:r>
               <a:rPr lang="en-US" sz="1800" b="1">
                 <a:solidFill>
-                  <a:srgbClr val="F5F5F7"/>
+                  <a:srgbClr val="F4F2FF"/>
                 </a:solidFill>
                 <a:latin typeface="Arial"/>
                 <a:ea typeface="Arial"/>
@@ -6638,7 +6646,7 @@
             <a:avLst/>
           </a:prstGeom>
           <a:solidFill xmlns:a="http://schemas.openxmlformats.org/drawingml/2006/main">
-            <a:srgbClr val="1C1C1E"/>
+            <a:srgbClr val="16162E"/>
           </a:solidFill>
           <a:ln xmlns:a="http://schemas.openxmlformats.org/drawingml/2006/main">
             <a:noFill/>
@@ -6673,7 +6681,7 @@
             <a:r>
               <a:rPr lang="en-US" sz="1800" b="1">
                 <a:solidFill>
-                  <a:srgbClr val="F5F5F7"/>
+                  <a:srgbClr val="F4F2FF"/>
                 </a:solidFill>
                 <a:latin typeface="Arial"/>
                 <a:ea typeface="Arial"/>
@@ -6758,7 +6766,7 @@
             <a:avLst/>
           </a:prstGeom>
           <a:solidFill xmlns:a="http://schemas.openxmlformats.org/drawingml/2006/main">
-            <a:srgbClr val="1C1C1E"/>
+            <a:srgbClr val="16162E"/>
           </a:solidFill>
           <a:ln xmlns:a="http://schemas.openxmlformats.org/drawingml/2006/main">
             <a:noFill/>
@@ -6793,7 +6801,7 @@
             <a:r>
               <a:rPr lang="en-US" sz="1800" b="1">
                 <a:solidFill>
-                  <a:srgbClr val="F5F5F7"/>
+                  <a:srgbClr val="F4F2FF"/>
                 </a:solidFill>
                 <a:latin typeface="Arial"/>
                 <a:ea typeface="Arial"/>
@@ -6818,7 +6826,7 @@
             <a:avLst/>
           </a:prstGeom>
           <a:solidFill xmlns:a="http://schemas.openxmlformats.org/drawingml/2006/main">
-            <a:srgbClr val="30D158"/>
+            <a:srgbClr val="3DDC97"/>
           </a:solidFill>
           <a:ln xmlns:a="http://schemas.openxmlformats.org/drawingml/2006/main">
             <a:noFill/>
@@ -6976,7 +6984,7 @@
     <p:bg>
       <p:bgPr>
         <a:solidFill xmlns:a="http://schemas.openxmlformats.org/drawingml/2006/main">
-          <a:srgbClr val="000000"/>
+          <a:srgbClr val="0B0B1A"/>
         </a:solidFill>
       </p:bgPr>
     </p:bg>
@@ -7010,7 +7018,7 @@
             <a:r>
               <a:rPr lang="en-US" sz="3600" b="1">
                 <a:solidFill>
-                  <a:srgbClr val="F5F5F7"/>
+                  <a:srgbClr val="F4F2FF"/>
                 </a:solidFill>
                 <a:latin typeface="Arial"/>
                 <a:ea typeface="Arial"/>
@@ -7035,7 +7043,7 @@
             <a:avLst/>
           </a:prstGeom>
           <a:solidFill xmlns:a="http://schemas.openxmlformats.org/drawingml/2006/main">
-            <a:srgbClr val="000000"/>
+            <a:srgbClr val="0B0B1A"/>
           </a:solidFill>
           <a:ln xmlns:a="http://schemas.openxmlformats.org/drawingml/2006/main">
             <a:noFill/>
@@ -7048,7 +7056,7 @@
             <a:r>
               <a:rPr lang="en-US" sz="1800" b="1">
                 <a:solidFill>
-                  <a:srgbClr val="F5F5F7"/>
+                  <a:srgbClr val="F4F2FF"/>
                 </a:solidFill>
                 <a:latin typeface="Arial"/>
                 <a:ea typeface="Arial"/>
@@ -7073,7 +7081,7 @@
             <a:avLst/>
           </a:prstGeom>
           <a:solidFill xmlns:a="http://schemas.openxmlformats.org/drawingml/2006/main">
-            <a:srgbClr val="1C1C1E"/>
+            <a:srgbClr val="16162E"/>
           </a:solidFill>
           <a:ln xmlns:a="http://schemas.openxmlformats.org/drawingml/2006/main">
             <a:noFill/>
@@ -7086,7 +7094,7 @@
             <a:r>
               <a:rPr lang="en-US" sz="1800" b="0">
                 <a:solidFill>
-                  <a:srgbClr val="F5F5F7"/>
+                  <a:srgbClr val="F4F2FF"/>
                 </a:solidFill>
                 <a:latin typeface="Arial"/>
                 <a:ea typeface="Arial"/>
@@ -7111,7 +7119,7 @@
             <a:avLst/>
           </a:prstGeom>
           <a:solidFill xmlns:a="http://schemas.openxmlformats.org/drawingml/2006/main">
-            <a:srgbClr val="000000"/>
+            <a:srgbClr val="0B0B1A"/>
           </a:solidFill>
           <a:ln xmlns:a="http://schemas.openxmlformats.org/drawingml/2006/main">
             <a:noFill/>
@@ -7124,7 +7132,7 @@
             <a:r>
               <a:rPr lang="en-US" sz="1800" b="1">
                 <a:solidFill>
-                  <a:srgbClr val="F5F5F7"/>
+                  <a:srgbClr val="F4F2FF"/>
                 </a:solidFill>
                 <a:latin typeface="Arial"/>
                 <a:ea typeface="Arial"/>
@@ -7149,7 +7157,7 @@
             <a:avLst/>
           </a:prstGeom>
           <a:solidFill xmlns:a="http://schemas.openxmlformats.org/drawingml/2006/main">
-            <a:srgbClr val="1C1C1E"/>
+            <a:srgbClr val="16162E"/>
           </a:solidFill>
           <a:ln xmlns:a="http://schemas.openxmlformats.org/drawingml/2006/main">
             <a:noFill/>
@@ -7162,7 +7170,7 @@
             <a:r>
               <a:rPr lang="en-US" sz="1800" b="0">
                 <a:solidFill>
-                  <a:srgbClr val="F5F5F7"/>
+                  <a:srgbClr val="F4F2FF"/>
                 </a:solidFill>
                 <a:latin typeface="Arial"/>
                 <a:ea typeface="Arial"/>
@@ -7285,7 +7293,7 @@
     <p:bg>
       <p:bgPr>
         <a:solidFill xmlns:a="http://schemas.openxmlformats.org/drawingml/2006/main">
-          <a:srgbClr val="000000"/>
+          <a:srgbClr val="0B0B1A"/>
         </a:solidFill>
       </p:bgPr>
     </p:bg>
@@ -7311,7 +7319,7 @@
             <a:avLst/>
           </a:prstGeom>
           <a:solidFill xmlns:a="http://schemas.openxmlformats.org/drawingml/2006/main">
-            <a:srgbClr val="0B5FFF"/>
+            <a:srgbClr val="7C5CFF"/>
           </a:solidFill>
           <a:ln xmlns:a="http://schemas.openxmlformats.org/drawingml/2006/main">
             <a:noFill/>
@@ -7346,7 +7354,7 @@
             <a:r>
               <a:rPr lang="en-US" sz="5400" b="1">
                 <a:solidFill>
-                  <a:srgbClr val="0B5FFF"/>
+                  <a:srgbClr val="7C5CFF"/>
                 </a:solidFill>
                 <a:latin typeface="Arial"/>
                 <a:ea typeface="Arial"/>
@@ -7379,7 +7387,7 @@
             <a:r>
               <a:rPr lang="en-US" sz="3600" b="1">
                 <a:solidFill>
-                  <a:srgbClr val="F5F5F7"/>
+                  <a:srgbClr val="F4F2FF"/>
                 </a:solidFill>
                 <a:latin typeface="Arial"/>
                 <a:ea typeface="Arial"/>
@@ -7535,7 +7543,7 @@
     <p:bg>
       <p:bgPr>
         <a:solidFill xmlns:a="http://schemas.openxmlformats.org/drawingml/2006/main">
-          <a:srgbClr val="000000"/>
+          <a:srgbClr val="0B0B1A"/>
         </a:solidFill>
       </p:bgPr>
     </p:bg>
@@ -7570,7 +7578,7 @@
             <a:r>
               <a:rPr lang="en-US" sz="4400" b="1">
                 <a:solidFill>
-                  <a:srgbClr val="F5F5F7"/>
+                  <a:srgbClr val="F4F2FF"/>
                 </a:solidFill>
                 <a:latin typeface="Arial"/>
                 <a:ea typeface="Arial"/>
@@ -7629,7 +7637,7 @@
             <a:avLst/>
           </a:prstGeom>
           <a:solidFill xmlns:a="http://schemas.openxmlformats.org/drawingml/2006/main">
-            <a:srgbClr val="0B5FFF"/>
+            <a:srgbClr val="7C5CFF"/>
           </a:solidFill>
           <a:ln xmlns:a="http://schemas.openxmlformats.org/drawingml/2006/main">
             <a:noFill/>
@@ -7766,7 +7774,7 @@
     <p:bg>
       <p:bgPr>
         <a:solidFill xmlns:a="http://schemas.openxmlformats.org/drawingml/2006/main">
-          <a:srgbClr val="000000"/>
+          <a:srgbClr val="0B0B1A"/>
         </a:solidFill>
       </p:bgPr>
     </p:bg>
@@ -7800,7 +7808,7 @@
             <a:r>
               <a:rPr lang="en-US" sz="3600" b="1">
                 <a:solidFill>
-                  <a:srgbClr val="F5F5F7"/>
+                  <a:srgbClr val="F4F2FF"/>
                 </a:solidFill>
                 <a:latin typeface="Arial"/>
                 <a:ea typeface="Arial"/>
@@ -7825,7 +7833,7 @@
             <a:avLst/>
           </a:prstGeom>
           <a:solidFill xmlns:a="http://schemas.openxmlformats.org/drawingml/2006/main">
-            <a:srgbClr val="1C1C1E"/>
+            <a:srgbClr val="16162E"/>
           </a:solidFill>
           <a:ln xmlns:a="http://schemas.openxmlformats.org/drawingml/2006/main">
             <a:noFill/>
@@ -7861,7 +7869,7 @@
             <a:r>
               <a:rPr lang="en-US" sz="6000" b="1">
                 <a:solidFill>
-                  <a:srgbClr val="F5F5F7"/>
+                  <a:srgbClr val="7C5CFF"/>
                 </a:solidFill>
                 <a:latin typeface="Arial"/>
                 <a:ea typeface="Arial"/>
@@ -7928,7 +7936,7 @@
             <a:pPr algn="ctr"/>
             <a:endParaRPr lang="en-US" sz="1200" b="1">
               <a:solidFill>
-                <a:srgbClr val="0B5FFF"/>
+                <a:srgbClr val="7C5CFF"/>
               </a:solidFill>
               <a:latin typeface="Arial"/>
               <a:ea typeface="Arial"/>
@@ -7951,7 +7959,7 @@
             <a:avLst/>
           </a:prstGeom>
           <a:solidFill xmlns:a="http://schemas.openxmlformats.org/drawingml/2006/main">
-            <a:srgbClr val="1C1C1E"/>
+            <a:srgbClr val="16162E"/>
           </a:solidFill>
           <a:ln xmlns:a="http://schemas.openxmlformats.org/drawingml/2006/main">
             <a:noFill/>
@@ -7987,7 +7995,7 @@
             <a:r>
               <a:rPr lang="en-US" sz="6000" b="1">
                 <a:solidFill>
-                  <a:srgbClr val="F5F5F7"/>
+                  <a:srgbClr val="22D3EE"/>
                 </a:solidFill>
                 <a:latin typeface="Arial"/>
                 <a:ea typeface="Arial"/>
@@ -8054,7 +8062,7 @@
             <a:pPr algn="ctr"/>
             <a:endParaRPr lang="en-US" sz="1200" b="1">
               <a:solidFill>
-                <a:srgbClr val="0B5FFF"/>
+                <a:srgbClr val="22D3EE"/>
               </a:solidFill>
               <a:latin typeface="Arial"/>
               <a:ea typeface="Arial"/>
@@ -8077,7 +8085,7 @@
             <a:avLst/>
           </a:prstGeom>
           <a:solidFill xmlns:a="http://schemas.openxmlformats.org/drawingml/2006/main">
-            <a:srgbClr val="1C1C1E"/>
+            <a:srgbClr val="16162E"/>
           </a:solidFill>
           <a:ln xmlns:a="http://schemas.openxmlformats.org/drawingml/2006/main">
             <a:noFill/>
@@ -8113,7 +8121,7 @@
             <a:r>
               <a:rPr lang="en-US" sz="6000" b="1">
                 <a:solidFill>
-                  <a:srgbClr val="F5F5F7"/>
+                  <a:srgbClr val="F472B6"/>
                 </a:solidFill>
                 <a:latin typeface="Arial"/>
                 <a:ea typeface="Arial"/>
@@ -8180,7 +8188,7 @@
             <a:pPr algn="ctr"/>
             <a:endParaRPr lang="en-US" sz="1200" b="1">
               <a:solidFill>
-                <a:srgbClr val="0B5FFF"/>
+                <a:srgbClr val="F472B6"/>
               </a:solidFill>
               <a:latin typeface="Arial"/>
               <a:ea typeface="Arial"/>
@@ -8301,7 +8309,7 @@
     <p:bg>
       <p:bgPr>
         <a:solidFill xmlns:a="http://schemas.openxmlformats.org/drawingml/2006/main">
-          <a:srgbClr val="000000"/>
+          <a:srgbClr val="0B0B1A"/>
         </a:solidFill>
       </p:bgPr>
     </p:bg>
@@ -8336,7 +8344,7 @@
             <a:r>
               <a:rPr lang="en-US" sz="8100" b="1">
                 <a:solidFill>
-                  <a:srgbClr val="0B5FFF"/>
+                  <a:srgbClr val="7C5CFF"/>
                 </a:solidFill>
                 <a:latin typeface="Arial"/>
                 <a:ea typeface="Arial"/>
@@ -8370,7 +8378,7 @@
             <a:r>
               <a:rPr lang="en-US" sz="2800" b="1">
                 <a:solidFill>
-                  <a:srgbClr val="F5F5F7"/>
+                  <a:srgbClr val="F4F2FF"/>
                 </a:solidFill>
                 <a:latin typeface="Arial"/>
                 <a:ea typeface="Arial"/>
@@ -8527,7 +8535,7 @@
     <p:bg>
       <p:bgPr>
         <a:solidFill xmlns:a="http://schemas.openxmlformats.org/drawingml/2006/main">
-          <a:srgbClr val="000000"/>
+          <a:srgbClr val="0B0B1A"/>
         </a:solidFill>
       </p:bgPr>
     </p:bg>
@@ -8561,7 +8569,7 @@
             <a:r>
               <a:rPr lang="en-US" sz="3600" b="1">
                 <a:solidFill>
-                  <a:srgbClr val="F5F5F7"/>
+                  <a:srgbClr val="F4F2FF"/>
                 </a:solidFill>
                 <a:latin typeface="Arial"/>
                 <a:ea typeface="Arial"/>
@@ -8586,7 +8594,7 @@
             <a:avLst/>
           </a:prstGeom>
           <a:solidFill xmlns:a="http://schemas.openxmlformats.org/drawingml/2006/main">
-            <a:srgbClr val="1C1C1E"/>
+            <a:srgbClr val="16162E"/>
           </a:solidFill>
           <a:ln xmlns:a="http://schemas.openxmlformats.org/drawingml/2006/main">
             <a:noFill/>
@@ -8621,7 +8629,7 @@
             <a:r>
               <a:rPr lang="en-US" sz="2800" b="1">
                 <a:solidFill>
-                  <a:srgbClr val="F5F5F7"/>
+                  <a:srgbClr val="F4F2FF"/>
                 </a:solidFill>
                 <a:latin typeface="Arial"/>
                 <a:ea typeface="Arial"/>
@@ -8703,7 +8711,7 @@
             <a:avLst/>
           </a:prstGeom>
           <a:solidFill xmlns:a="http://schemas.openxmlformats.org/drawingml/2006/main">
-            <a:srgbClr val="0B5FFF"/>
+            <a:srgbClr val="7C5CFF"/>
           </a:solidFill>
           <a:ln xmlns:a="http://schemas.openxmlformats.org/drawingml/2006/main">
             <a:noFill/>
@@ -8918,7 +8926,7 @@
     <p:bg>
       <p:bgPr>
         <a:solidFill xmlns:a="http://schemas.openxmlformats.org/drawingml/2006/main">
-          <a:srgbClr val="000000"/>
+          <a:srgbClr val="0B0B1A"/>
         </a:solidFill>
       </p:bgPr>
     </p:bg>
@@ -8952,7 +8960,7 @@
             <a:r>
               <a:rPr lang="en-US" sz="3600" b="1">
                 <a:solidFill>
-                  <a:srgbClr val="F5F5F7"/>
+                  <a:srgbClr val="F4F2FF"/>
                 </a:solidFill>
                 <a:latin typeface="Arial"/>
                 <a:ea typeface="Arial"/>
@@ -8977,7 +8985,7 @@
             <a:avLst/>
           </a:prstGeom>
           <a:solidFill xmlns:a="http://schemas.openxmlformats.org/drawingml/2006/main">
-            <a:srgbClr val="0B5FFF"/>
+            <a:srgbClr val="7C5CFF"/>
           </a:solidFill>
           <a:ln xmlns:a="http://schemas.openxmlformats.org/drawingml/2006/main">
             <a:noFill/>
@@ -9042,7 +9050,7 @@
             <a:avLst/>
           </a:prstGeom>
           <a:solidFill xmlns:a="http://schemas.openxmlformats.org/drawingml/2006/main">
-            <a:srgbClr val="1C1C1E"/>
+            <a:srgbClr val="22D3EE"/>
           </a:solidFill>
           <a:ln xmlns:a="http://schemas.openxmlformats.org/drawingml/2006/main">
             <a:noFill/>
@@ -9056,7 +9064,7 @@
             <a:r>
               <a:rPr lang="en-US" sz="1800" b="1">
                 <a:solidFill>
-                  <a:srgbClr val="F5F5F7"/>
+                  <a:srgbClr val="FFFFFF"/>
                 </a:solidFill>
                 <a:latin typeface="Arial"/>
                 <a:ea typeface="Arial"/>
@@ -9069,7 +9077,7 @@
             <a:r>
               <a:rPr lang="en-US" sz="1800" b="1">
                 <a:solidFill>
-                  <a:srgbClr val="F5F5F7"/>
+                  <a:srgbClr val="FFFFFF"/>
                 </a:solidFill>
                 <a:latin typeface="Arial"/>
                 <a:ea typeface="Arial"/>
@@ -9082,7 +9090,7 @@
             <a:r>
               <a:rPr lang="en-US" sz="1800" b="1">
                 <a:solidFill>
-                  <a:srgbClr val="F5F5F7"/>
+                  <a:srgbClr val="FFFFFF"/>
                 </a:solidFill>
                 <a:latin typeface="Arial"/>
                 <a:ea typeface="Arial"/>
@@ -9107,7 +9115,7 @@
             <a:avLst/>
           </a:prstGeom>
           <a:solidFill xmlns:a="http://schemas.openxmlformats.org/drawingml/2006/main">
-            <a:srgbClr val="1C1C1E"/>
+            <a:srgbClr val="F472B6"/>
           </a:solidFill>
           <a:ln xmlns:a="http://schemas.openxmlformats.org/drawingml/2006/main">
             <a:noFill/>
@@ -9121,7 +9129,7 @@
             <a:r>
               <a:rPr lang="en-US" sz="1800" b="1">
                 <a:solidFill>
-                  <a:srgbClr val="F5F5F7"/>
+                  <a:srgbClr val="FFFFFF"/>
                 </a:solidFill>
                 <a:latin typeface="Arial"/>
                 <a:ea typeface="Arial"/>
@@ -9134,7 +9142,7 @@
             <a:r>
               <a:rPr lang="en-US" sz="1800" b="1">
                 <a:solidFill>
-                  <a:srgbClr val="F5F5F7"/>
+                  <a:srgbClr val="FFFFFF"/>
                 </a:solidFill>
                 <a:latin typeface="Arial"/>
                 <a:ea typeface="Arial"/>
@@ -9147,7 +9155,7 @@
             <a:r>
               <a:rPr lang="en-US" sz="1800" b="1">
                 <a:solidFill>
-                  <a:srgbClr val="F5F5F7"/>
+                  <a:srgbClr val="FFFFFF"/>
                 </a:solidFill>
                 <a:latin typeface="Arial"/>
                 <a:ea typeface="Arial"/>
@@ -9172,7 +9180,7 @@
             <a:avLst/>
           </a:prstGeom>
           <a:solidFill xmlns:a="http://schemas.openxmlformats.org/drawingml/2006/main">
-            <a:srgbClr val="0B5FFF"/>
+            <a:srgbClr val="3DDC97"/>
           </a:solidFill>
           <a:ln xmlns:a="http://schemas.openxmlformats.org/drawingml/2006/main">
             <a:noFill/>
@@ -9410,7 +9418,7 @@
     <p:bg>
       <p:bgPr>
         <a:solidFill xmlns:a="http://schemas.openxmlformats.org/drawingml/2006/main">
-          <a:srgbClr val="000000"/>
+          <a:srgbClr val="0B0B1A"/>
         </a:solidFill>
       </p:bgPr>
     </p:bg>
@@ -9444,7 +9452,7 @@
             <a:r>
               <a:rPr lang="en-US" sz="3600" b="1">
                 <a:solidFill>
-                  <a:srgbClr val="F5F5F7"/>
+                  <a:srgbClr val="F4F2FF"/>
                 </a:solidFill>
                 <a:latin typeface="Arial"/>
                 <a:ea typeface="Arial"/>
@@ -9469,7 +9477,7 @@
             <a:avLst/>
           </a:prstGeom>
           <a:solidFill xmlns:a="http://schemas.openxmlformats.org/drawingml/2006/main">
-            <a:srgbClr val="1C1C1E"/>
+            <a:srgbClr val="7C5CFF"/>
           </a:solidFill>
           <a:ln xmlns:a="http://schemas.openxmlformats.org/drawingml/2006/main">
             <a:noFill/>
@@ -9505,7 +9513,7 @@
             <a:r>
               <a:rPr lang="en-US" sz="2200" b="1">
                 <a:solidFill>
-                  <a:srgbClr val="F5F5F7"/>
+                  <a:srgbClr val="FFFFFF"/>
                 </a:solidFill>
                 <a:latin typeface="Arial"/>
                 <a:ea typeface="Arial"/>
@@ -9530,7 +9538,7 @@
             <a:avLst/>
           </a:prstGeom>
           <a:solidFill xmlns:a="http://schemas.openxmlformats.org/drawingml/2006/main">
-            <a:srgbClr val="1C1C1E"/>
+            <a:srgbClr val="22D3EE"/>
           </a:solidFill>
           <a:ln xmlns:a="http://schemas.openxmlformats.org/drawingml/2006/main">
             <a:noFill/>
@@ -9566,7 +9574,7 @@
             <a:r>
               <a:rPr lang="en-US" sz="2200" b="1">
                 <a:solidFill>
-                  <a:srgbClr val="F5F5F7"/>
+                  <a:srgbClr val="FFFFFF"/>
                 </a:solidFill>
                 <a:latin typeface="Arial"/>
                 <a:ea typeface="Arial"/>
@@ -9591,7 +9599,7 @@
             <a:avLst/>
           </a:prstGeom>
           <a:solidFill xmlns:a="http://schemas.openxmlformats.org/drawingml/2006/main">
-            <a:srgbClr val="1C1C1E"/>
+            <a:srgbClr val="F472B6"/>
           </a:solidFill>
           <a:ln xmlns:a="http://schemas.openxmlformats.org/drawingml/2006/main">
             <a:noFill/>
@@ -9627,7 +9635,7 @@
             <a:r>
               <a:rPr lang="en-US" sz="2200" b="1">
                 <a:solidFill>
-                  <a:srgbClr val="F5F5F7"/>
+                  <a:srgbClr val="FFFFFF"/>
                 </a:solidFill>
                 <a:latin typeface="Arial"/>
                 <a:ea typeface="Arial"/>
@@ -9652,7 +9660,7 @@
             <a:avLst/>
           </a:prstGeom>
           <a:solidFill xmlns:a="http://schemas.openxmlformats.org/drawingml/2006/main">
-            <a:srgbClr val="0B5FFF"/>
+            <a:srgbClr val="3DDC97"/>
           </a:solidFill>
           <a:ln xmlns:a="http://schemas.openxmlformats.org/drawingml/2006/main">
             <a:noFill/>
@@ -9811,7 +9819,7 @@
     <p:bg>
       <p:bgPr>
         <a:solidFill xmlns:a="http://schemas.openxmlformats.org/drawingml/2006/main">
-          <a:srgbClr val="000000"/>
+          <a:srgbClr val="0B0B1A"/>
         </a:solidFill>
       </p:bgPr>
     </p:bg>
@@ -9845,7 +9853,7 @@
             <a:r>
               <a:rPr lang="en-US" sz="3600" b="1">
                 <a:solidFill>
-                  <a:srgbClr val="F5F5F7"/>
+                  <a:srgbClr val="F4F2FF"/>
                 </a:solidFill>
                 <a:latin typeface="Arial"/>
                 <a:ea typeface="Arial"/>
@@ -9870,7 +9878,7 @@
             <a:avLst/>
           </a:prstGeom>
           <a:solidFill xmlns:a="http://schemas.openxmlformats.org/drawingml/2006/main">
-            <a:srgbClr val="1C1C1E"/>
+            <a:srgbClr val="16162E"/>
           </a:solidFill>
           <a:ln xmlns:a="http://schemas.openxmlformats.org/drawingml/2006/main">
             <a:noFill/>
@@ -9905,7 +9913,7 @@
             <a:r>
               <a:rPr lang="en-US" sz="3400" b="1">
                 <a:solidFill>
-                  <a:srgbClr val="0B5FFF"/>
+                  <a:srgbClr val="7C5CFF"/>
                 </a:solidFill>
                 <a:latin typeface="Arial"/>
                 <a:ea typeface="Arial"/>
@@ -9938,7 +9946,7 @@
             <a:r>
               <a:rPr lang="en-US" sz="2600" b="1">
                 <a:solidFill>
-                  <a:srgbClr val="F5F5F7"/>
+                  <a:srgbClr val="F4F2FF"/>
                 </a:solidFill>
                 <a:latin typeface="Arial"/>
                 <a:ea typeface="Arial"/>
@@ -9996,7 +10004,7 @@
             <a:avLst/>
           </a:prstGeom>
           <a:solidFill xmlns:a="http://schemas.openxmlformats.org/drawingml/2006/main">
-            <a:srgbClr val="1C1C1E"/>
+            <a:srgbClr val="16162E"/>
           </a:solidFill>
           <a:ln xmlns:a="http://schemas.openxmlformats.org/drawingml/2006/main">
             <a:noFill/>
@@ -10031,7 +10039,7 @@
             <a:r>
               <a:rPr lang="en-US" sz="3400" b="1">
                 <a:solidFill>
-                  <a:srgbClr val="0B5FFF"/>
+                  <a:srgbClr val="22D3EE"/>
                 </a:solidFill>
                 <a:latin typeface="Arial"/>
                 <a:ea typeface="Arial"/>
@@ -10064,7 +10072,7 @@
             <a:r>
               <a:rPr lang="en-US" sz="2600" b="1">
                 <a:solidFill>
-                  <a:srgbClr val="F5F5F7"/>
+                  <a:srgbClr val="F4F2FF"/>
                 </a:solidFill>
                 <a:latin typeface="Arial"/>
                 <a:ea typeface="Arial"/>
@@ -10122,7 +10130,7 @@
             <a:avLst/>
           </a:prstGeom>
           <a:solidFill xmlns:a="http://schemas.openxmlformats.org/drawingml/2006/main">
-            <a:srgbClr val="1C1C1E"/>
+            <a:srgbClr val="16162E"/>
           </a:solidFill>
           <a:ln xmlns:a="http://schemas.openxmlformats.org/drawingml/2006/main">
             <a:noFill/>
@@ -10157,7 +10165,7 @@
             <a:r>
               <a:rPr lang="en-US" sz="3400" b="1">
                 <a:solidFill>
-                  <a:srgbClr val="0B5FFF"/>
+                  <a:srgbClr val="F472B6"/>
                 </a:solidFill>
                 <a:latin typeface="Arial"/>
                 <a:ea typeface="Arial"/>
@@ -10190,7 +10198,7 @@
             <a:r>
               <a:rPr lang="en-US" sz="2600" b="1">
                 <a:solidFill>
-                  <a:srgbClr val="F5F5F7"/>
+                  <a:srgbClr val="F4F2FF"/>
                 </a:solidFill>
                 <a:latin typeface="Arial"/>
                 <a:ea typeface="Arial"/>
@@ -10346,7 +10354,7 @@
     <p:bg>
       <p:bgPr>
         <a:solidFill xmlns:a="http://schemas.openxmlformats.org/drawingml/2006/main">
-          <a:srgbClr val="000000"/>
+          <a:srgbClr val="0B0B1A"/>
         </a:solidFill>
       </p:bgPr>
     </p:bg>
@@ -10372,7 +10380,7 @@
             <a:avLst/>
           </a:prstGeom>
           <a:solidFill xmlns:a="http://schemas.openxmlformats.org/drawingml/2006/main">
-            <a:srgbClr val="0B5FFF"/>
+            <a:srgbClr val="7C5CFF"/>
           </a:solidFill>
           <a:ln xmlns:a="http://schemas.openxmlformats.org/drawingml/2006/main">
             <a:noFill/>
@@ -10407,7 +10415,7 @@
             <a:r>
               <a:rPr lang="en-US" sz="5400" b="1">
                 <a:solidFill>
-                  <a:srgbClr val="0B5FFF"/>
+                  <a:srgbClr val="7C5CFF"/>
                 </a:solidFill>
                 <a:latin typeface="Arial"/>
                 <a:ea typeface="Arial"/>
@@ -10440,7 +10448,7 @@
             <a:r>
               <a:rPr lang="en-US" sz="3600" b="1">
                 <a:solidFill>
-                  <a:srgbClr val="F5F5F7"/>
+                  <a:srgbClr val="F4F2FF"/>
                 </a:solidFill>
                 <a:latin typeface="Arial"/>
                 <a:ea typeface="Arial"/>

</xml_diff>